<commit_message>
Phase 1 item 2: XGBoost build, regenerated model card and deck
Full build on official OULAD with XGBoost 3.4 (exact TreeSHAP drivers). Withdrawal
ROC-AUC stays within 0.02 of the sklearn reference run at every checkpoint and
the official quality gate passes; the comparison is recorded in docs/HANDOFF.md.

Fixes found on the way:
- report: write MODEL_CARD.md as UTF-8 (crashed on Windows cp1252)
- llm-eval --no-llm: no longer calls the LLM judge when a key is configured
  (regression test with FakeLLM)
- offline eval: skip copilot golden questions for modules missing from the
  latest presentation instead of failing

Co-Authored-By: Claude Opus 5.5 <noreply@anthropic.com>
</commit_message>
<xml_diff>
--- a/docs/Student_Success_Assistant_10min.pptx
+++ b/docs/Student_Success_Assistant_10min.pptx
@@ -184,10 +184,10 @@
                 <c:formatCode>General</c:formatCode>
                 <c:ptCount val="2"/>
                 <c:pt idx="0">
-                  <c:v>0.7825432370815432</c:v>
+                  <c:v>0.7493848462743269</c:v>
                 </c:pt>
                 <c:pt idx="1">
-                  <c:v>0.7304031575424712</c:v>
+                  <c:v>0.7255685308195328</c:v>
                 </c:pt>
               </c:numCache>
             </c:numRef>
@@ -352,13 +352,13 @@
                 <c:formatCode>General</c:formatCode>
                 <c:ptCount val="3"/>
                 <c:pt idx="0">
-                  <c:v>0.2551683402244536</c:v>
+                  <c:v>0.23588205897051473</c:v>
                 </c:pt>
                 <c:pt idx="1">
-                  <c:v>0.11797752808988764</c:v>
+                  <c:v>0.11739502999143102</c:v>
                 </c:pt>
                 <c:pt idx="2">
-                  <c:v>0.04562043795620438</c:v>
+                  <c:v>0.0487382483918852</c:v>
                 </c:pt>
               </c:numCache>
             </c:numRef>
@@ -525,16 +525,16 @@
                 <c:formatCode>General</c:formatCode>
                 <c:ptCount val="4"/>
                 <c:pt idx="0">
-                  <c:v>0.6930342957193047</c:v>
+                  <c:v>0.6861329556239586</c:v>
                 </c:pt>
                 <c:pt idx="1">
-                  <c:v>0.7025102917872399</c:v>
+                  <c:v>0.7003070619008248</c:v>
                 </c:pt>
                 <c:pt idx="2">
-                  <c:v>0.7304031575424712</c:v>
+                  <c:v>0.7255685308195328</c:v>
                 </c:pt>
                 <c:pt idx="3">
-                  <c:v>0.7582281081505631</c:v>
+                  <c:v>0.773455500635073</c:v>
                 </c:pt>
               </c:numCache>
             </c:numRef>
@@ -586,16 +586,16 @@
                 <c:formatCode>General</c:formatCode>
                 <c:ptCount val="4"/>
                 <c:pt idx="0">
-                  <c:v>0.34658527977038667</c:v>
+                  <c:v>0.31596324382933005</c:v>
                 </c:pt>
                 <c:pt idx="1">
-                  <c:v>0.28141943452162194</c:v>
+                  <c:v>0.2893076585124664</c:v>
                 </c:pt>
                 <c:pt idx="2">
-                  <c:v>0.2655579599478286</c:v>
+                  <c:v>0.26301911267610545</c:v>
                 </c:pt>
                 <c:pt idx="3">
-                  <c:v>0.1729306503799273</c:v>
+                  <c:v>0.1759725473938002</c:v>
                 </c:pt>
               </c:numCache>
             </c:numRef>
@@ -1020,16 +1020,16 @@
                 <c:formatCode>General</c:formatCode>
                 <c:ptCount val="4"/>
                 <c:pt idx="0">
-                  <c:v>0.8018848222210619</c:v>
+                  <c:v>0.8353588516746411</c:v>
                 </c:pt>
                 <c:pt idx="1">
-                  <c:v>0.7850467289719627</c:v>
+                  <c:v>0.8292404306220096</c:v>
                 </c:pt>
                 <c:pt idx="2">
-                  <c:v>0.8319236325031761</c:v>
+                  <c:v>0.8364712918660288</c:v>
                 </c:pt>
                 <c:pt idx="3">
-                  <c:v>0.5054038531822691</c:v>
+                  <c:v>0.5120334928229665</c:v>
                 </c:pt>
               </c:numCache>
             </c:numRef>
@@ -1081,16 +1081,16 @@
                 <c:formatCode>General</c:formatCode>
                 <c:ptCount val="4"/>
                 <c:pt idx="0">
-                  <c:v>0.8795900017902634</c:v>
+                  <c:v>0.866087173772427</c:v>
                 </c:pt>
                 <c:pt idx="1">
-                  <c:v>0.8742628145864164</c:v>
+                  <c:v>0.8703634727791237</c:v>
                 </c:pt>
                 <c:pt idx="2">
-                  <c:v>0.7554797518173918</c:v>
+                  <c:v>0.7541412072228056</c:v>
                 </c:pt>
                 <c:pt idx="3">
-                  <c:v>0.5460183737202833</c:v>
+                  <c:v>0.5441068784899428</c:v>
                 </c:pt>
               </c:numCache>
             </c:numRef>
@@ -1259,13 +1259,13 @@
                 <c:formatCode>General</c:formatCode>
                 <c:ptCount val="4"/>
                 <c:pt idx="0">
-                  <c:v>0.9856801909307876</c:v>
+                  <c:v>0.9797136038186157</c:v>
                 </c:pt>
                 <c:pt idx="1">
-                  <c:v>0.8400954653937948</c:v>
+                  <c:v>0.8448687350835322</c:v>
                 </c:pt>
                 <c:pt idx="2">
-                  <c:v>0.7816229116945107</c:v>
+                  <c:v>0.7804295942720764</c:v>
                 </c:pt>
                 <c:pt idx="3">
                   <c:v>0.3436754176610978</c:v>
@@ -1320,13 +1320,13 @@
                 <c:formatCode>General</c:formatCode>
                 <c:ptCount val="4"/>
                 <c:pt idx="0">
-                  <c:v>0.8573134328358208</c:v>
+                  <c:v>0.8507462686567164</c:v>
                 </c:pt>
                 <c:pt idx="1">
-                  <c:v>0.7564179104477612</c:v>
+                  <c:v>0.7534328358208955</c:v>
                 </c:pt>
                 <c:pt idx="2">
-                  <c:v>0.6961194029850746</c:v>
+                  <c:v>0.7026865671641791</c:v>
                 </c:pt>
                 <c:pt idx="3">
                   <c:v>0.35880597014925375</c:v>
@@ -1504,22 +1504,22 @@
                 <c:formatCode>General</c:formatCode>
                 <c:ptCount val="6"/>
                 <c:pt idx="0">
-                  <c:v>0.09279091997438588</c:v>
+                  <c:v>0.08185386949783308</c:v>
                 </c:pt>
                 <c:pt idx="1">
-                  <c:v>0.26136363636363635</c:v>
+                  <c:v>0.26456876456876455</c:v>
                 </c:pt>
                 <c:pt idx="2">
-                  <c:v>0.028867518400222225</c:v>
+                  <c:v>0.14045057844530134</c:v>
                 </c:pt>
                 <c:pt idx="3">
-                  <c:v>0.16175325397708307</c:v>
+                  <c:v>0.1949308755760369</c:v>
                 </c:pt>
                 <c:pt idx="4">
-                  <c:v>0.06536721717236377</c:v>
+                  <c:v>0.04795587419451197</c:v>
                 </c:pt>
                 <c:pt idx="5">
-                  <c:v>0.21111111111111108</c:v>
+                  <c:v>0.23212560386473435</c:v>
                 </c:pt>
               </c:numCache>
             </c:numRef>
@@ -7594,7 +7594,7 @@
                   <a:srgbClr val="0F766E"/>
                 </a:solidFill>
               </a:rPr>
-              <a:t>0.730</a:t>
+              <a:t>0.726</a:t>
             </a:r>
           </a:p>
         </p:txBody>
@@ -7632,7 +7632,7 @@
                   <a:srgbClr val="64748B"/>
                 </a:solidFill>
               </a:rPr>
-              <a:t>ROC-AUC (95% CI 0.713–0.745); logistic baseline 0.703</a:t>
+              <a:t>ROC-AUC (95% CI 0.708–0.740); logistic baseline 0.703</a:t>
             </a:r>
           </a:p>
         </p:txBody>
@@ -7670,7 +7670,7 @@
                   <a:srgbClr val="0F766E"/>
                 </a:solidFill>
               </a:rPr>
-              <a:t>0.006</a:t>
+              <a:t>0.009</a:t>
             </a:r>
           </a:p>
         </p:txBody>
@@ -7746,7 +7746,7 @@
                   <a:srgbClr val="0F766E"/>
                 </a:solidFill>
               </a:rPr>
-              <a:t>2.7×</a:t>
+              <a:t>2.6×</a:t>
             </a:r>
           </a:p>
         </p:txBody>
@@ -7822,7 +7822,7 @@
                   <a:srgbClr val="0F766E"/>
                 </a:solidFill>
               </a:rPr>
-              <a:t>45%</a:t>
+              <a:t>44%</a:t>
             </a:r>
           </a:p>
         </p:txBody>
@@ -8500,7 +8500,7 @@
                   <a:srgbClr val="1F2A44"/>
                 </a:solidFill>
               </a:rPr>
-              <a:t>Learned weights: p_poor 1.0</a:t>
+              <a:t>Learned weights: p_withdraw 0.1, p_poor 0.9</a:t>
             </a:r>
           </a:p>
           <a:p>

</xml_diff>

<commit_message>
Phase 1 item 3: dense retrieval channel built and benchmarked
Built the all-MiniLM-L6-v2 dense channel at every checkpoint and re-ran the
evaluation. Fusion weights were re-tuned with dense in the grid; validation
picked dense = 0.0 at all checkpoints, so hybrid results are unchanged. The
model card now includes the dense benchmark row; analysis is in HANDOFF.md.
Also ignore the deck's generated screenshot crop.

Co-Authored-By: Claude Opus 5.5 <noreply@anthropic.com>
</commit_message>
<xml_diff>
--- a/docs/Student_Success_Assistant_10min.pptx
+++ b/docs/Student_Success_Assistant_10min.pptx
@@ -995,9 +995,9 @@
           </c:spPr>
           <c:cat>
             <c:strRef>
-              <c:f>Sheet1!$A$2:$A$5</c:f>
+              <c:f>Sheet1!$A$2:$A$6</c:f>
               <c:strCache>
-                <c:ptCount val="4"/>
+                <c:ptCount val="5"/>
                 <c:pt idx="0">
                   <c:v>hybrid</c:v>
                 </c:pt>
@@ -1008,6 +1008,9 @@
                   <c:v>lexical</c:v>
                 </c:pt>
                 <c:pt idx="3">
+                  <c:v>dense</c:v>
+                </c:pt>
+                <c:pt idx="4">
                   <c:v>random</c:v>
                 </c:pt>
               </c:strCache>
@@ -1015,10 +1018,10 @@
           </c:cat>
           <c:val>
             <c:numRef>
-              <c:f>Sheet1!$B$2:$B$5</c:f>
+              <c:f>Sheet1!$B$2:$B$6</c:f>
               <c:numCache>
                 <c:formatCode>General</c:formatCode>
-                <c:ptCount val="4"/>
+                <c:ptCount val="5"/>
                 <c:pt idx="0">
                   <c:v>0.8353588516746411</c:v>
                 </c:pt>
@@ -1029,6 +1032,9 @@
                   <c:v>0.8364712918660288</c:v>
                 </c:pt>
                 <c:pt idx="3">
+                  <c:v>0.7752571770334928</c:v>
+                </c:pt>
+                <c:pt idx="4">
                   <c:v>0.5120334928229665</c:v>
                 </c:pt>
               </c:numCache>
@@ -1056,9 +1062,9 @@
           </c:spPr>
           <c:cat>
             <c:strRef>
-              <c:f>Sheet1!$A$2:$A$5</c:f>
+              <c:f>Sheet1!$A$2:$A$6</c:f>
               <c:strCache>
-                <c:ptCount val="4"/>
+                <c:ptCount val="5"/>
                 <c:pt idx="0">
                   <c:v>hybrid</c:v>
                 </c:pt>
@@ -1069,6 +1075,9 @@
                   <c:v>lexical</c:v>
                 </c:pt>
                 <c:pt idx="3">
+                  <c:v>dense</c:v>
+                </c:pt>
+                <c:pt idx="4">
                   <c:v>random</c:v>
                 </c:pt>
               </c:strCache>
@@ -1076,10 +1085,10 @@
           </c:cat>
           <c:val>
             <c:numRef>
-              <c:f>Sheet1!$C$2:$C$5</c:f>
+              <c:f>Sheet1!$C$2:$C$6</c:f>
               <c:numCache>
                 <c:formatCode>General</c:formatCode>
-                <c:ptCount val="4"/>
+                <c:ptCount val="5"/>
                 <c:pt idx="0">
                   <c:v>0.866087173772427</c:v>
                 </c:pt>
@@ -1090,6 +1099,9 @@
                   <c:v>0.7541412072228056</c:v>
                 </c:pt>
                 <c:pt idx="3">
+                  <c:v>0.7235239288679426</c:v>
+                </c:pt>
+                <c:pt idx="4">
                   <c:v>0.5441068784899428</c:v>
                 </c:pt>
               </c:numCache>

</xml_diff>

<commit_message>
Item 7: finer prioritisation search with a one-standard-error blend rule
- 0.05-step simplex grid with a one-sort objective identical to at_capacity
- PRIORITY_SELECTION=one_se_blend (default) picks the most blended weighting within
  one bootstrap SE of the validation best; argmax keeps the old behaviour
- test comparison reports both the chosen blend and validation_argmax
- `ssa.cli train --only prioritization` refits on the saved models
- model card and deck regenerated

Co-Authored-By: Claude Opus 5.5 <noreply@anthropic.com>
</commit_message>
<xml_diff>
--- a/docs/Student_Success_Assistant_10min.pptx
+++ b/docs/Student_Success_Assistant_10min.pptx
@@ -1271,7 +1271,7 @@
                 <c:formatCode>General</c:formatCode>
                 <c:ptCount val="4"/>
                 <c:pt idx="0">
-                  <c:v>0.9797136038186157</c:v>
+                  <c:v>0.9785202863961814</c:v>
                 </c:pt>
                 <c:pt idx="1">
                   <c:v>0.8448687350835322</c:v>
@@ -1332,7 +1332,7 @@
                 <c:formatCode>General</c:formatCode>
                 <c:ptCount val="4"/>
                 <c:pt idx="0">
-                  <c:v>0.8507462686567164</c:v>
+                  <c:v>0.8543283582089553</c:v>
                 </c:pt>
                 <c:pt idx="1">
                   <c:v>0.7534328358208955</c:v>
@@ -8512,7 +8512,7 @@
                   <a:srgbClr val="1F2A44"/>
                 </a:solidFill>
               </a:rPr>
-              <a:t>Learned weights: p_withdraw 0.1, p_poor 0.9</a:t>
+              <a:t>Learned weights: p_withdraw 0.10, p_poor 0.75, academic_gap 0.05, engagement_gap 0.05, missed_work 0.05</a:t>
             </a:r>
           </a:p>
           <a:p>

</xml_diff>

<commit_message>
Case-index vectors in a vector database (LanceDB)
Behavioural and dense vectors live in an embedded LanceDB table per checkpoint
with the filterable metadata and scalar indexes; metadata filters run as a
pre-filter and kNN is exact. Same top 10 as the NumPy scan on 1,800 sampled
searches. VECTOR_STORE=numpy keeps arrays; index --migrate-vectors converts
an existing index without re-encoding.

Co-Authored-By: Claude Opus 5.5 <noreply@anthropic.com>
</commit_message>
<xml_diff>
--- a/docs/Student_Success_Assistant_10min.pptx
+++ b/docs/Student_Success_Assistant_10min.pptx
@@ -1023,7 +1023,7 @@
                 <c:formatCode>General</c:formatCode>
                 <c:ptCount val="5"/>
                 <c:pt idx="0">
-                  <c:v>0.8353588516746411</c:v>
+                  <c:v>0.8349760765550238</c:v>
                 </c:pt>
                 <c:pt idx="1">
                   <c:v>0.8292404306220096</c:v>
@@ -1032,7 +1032,7 @@
                   <c:v>0.8364712918660288</c:v>
                 </c:pt>
                 <c:pt idx="3">
-                  <c:v>0.7752571770334928</c:v>
+                  <c:v>0.7747547846889953</c:v>
                 </c:pt>
                 <c:pt idx="4">
                   <c:v>0.5120334928229665</c:v>
@@ -1090,7 +1090,7 @@
                 <c:formatCode>General</c:formatCode>
                 <c:ptCount val="5"/>
                 <c:pt idx="0">
-                  <c:v>0.866087173772427</c:v>
+                  <c:v>0.8661044770467098</c:v>
                 </c:pt>
                 <c:pt idx="1">
                   <c:v>0.8703634727791237</c:v>
@@ -1099,7 +1099,7 @@
                   <c:v>0.7541412072228056</c:v>
                 </c:pt>
                 <c:pt idx="3">
-                  <c:v>0.7235239288679426</c:v>
+                  <c:v>0.7235297564802611</c:v>
                 </c:pt>
                 <c:pt idx="4">
                   <c:v>0.5441068784899428</c:v>

</xml_diff>

<commit_message>
Embedding model evaluation results; model card and deck regenerated
Five sentence-embedding models on the same narratives: e5-small-v2 and gte-small beat
the production MiniLM on the dense channel at the same latency. The decision log and
HANDOFF record the recommended switch.

Co-Authored-By: Claude Opus 5.5 <noreply@anthropic.com>
</commit_message>
<xml_diff>
--- a/docs/Student_Success_Assistant_10min.pptx
+++ b/docs/Student_Success_Assistant_10min.pptx
@@ -18,6 +18,8 @@
     <p:sldId id="266" r:id="rId18"/>
     <p:sldId id="267" r:id="rId19"/>
     <p:sldId id="268" r:id="rId20"/>
+    <p:sldId id="269" r:id="rId21"/>
+    <p:sldId id="270" r:id="rId22"/>
   </p:sldIdLst>
   <p:sldSz cx="12191695" cy="6858000" type="screen4x3"/>
   <p:notesSz cx="6858000" cy="9144000"/>
@@ -284,6 +286,194 @@
 </c:chartSpace>
 </file>
 
+<file path=ppt/charts/chart10.xml><?xml version="1.0" encoding="utf-8"?>
+<c:chartSpace xmlns:c="http://schemas.openxmlformats.org/drawingml/2006/chart" xmlns:a="http://schemas.openxmlformats.org/drawingml/2006/main" xmlns:r="http://schemas.openxmlformats.org/officeDocument/2006/relationships">
+  <c:date1904 val="0"/>
+  <c:chart>
+    <c:title>
+      <c:tx>
+        <c:rich>
+          <a:bodyPr/>
+          <a:lstStyle/>
+          <a:p>
+            <a:r>
+              <a:rPr sz="1400"/>
+              <a:t>Difference in true-positive rate between groups (High tier)</a:t>
+            </a:r>
+          </a:p>
+        </c:rich>
+      </c:tx>
+      <c:layout/>
+      <c:overlay val="0"/>
+    </c:title>
+    <c:autoTitleDeleted val="0"/>
+    <c:plotArea>
+      <c:barChart>
+        <c:barDir val="col"/>
+        <c:grouping val="clustered"/>
+        <c:ser>
+          <c:idx val="0"/>
+          <c:order val="0"/>
+          <c:tx>
+            <c:strRef>
+              <c:f>Sheet1!$B$1</c:f>
+              <c:strCache>
+                <c:ptCount val="1"/>
+                <c:pt idx="0">
+                  <c:v>Equal-opportunity gap</c:v>
+                </c:pt>
+              </c:strCache>
+            </c:strRef>
+          </c:tx>
+          <c:spPr>
+            <a:solidFill>
+              <a:srgbClr val="B45309"/>
+            </a:solidFill>
+          </c:spPr>
+          <c:cat>
+            <c:strRef>
+              <c:f>Sheet1!$A$2:$A$7</c:f>
+              <c:strCache>
+                <c:ptCount val="6"/>
+                <c:pt idx="0">
+                  <c:v>gender</c:v>
+                </c:pt>
+                <c:pt idx="1">
+                  <c:v>region</c:v>
+                </c:pt>
+                <c:pt idx="2">
+                  <c:v>highest_education</c:v>
+                </c:pt>
+                <c:pt idx="3">
+                  <c:v>imd_band</c:v>
+                </c:pt>
+                <c:pt idx="4">
+                  <c:v>age_band</c:v>
+                </c:pt>
+                <c:pt idx="5">
+                  <c:v>disability</c:v>
+                </c:pt>
+              </c:strCache>
+            </c:strRef>
+          </c:cat>
+          <c:val>
+            <c:numRef>
+              <c:f>Sheet1!$B$2:$B$7</c:f>
+              <c:numCache>
+                <c:formatCode>General</c:formatCode>
+                <c:ptCount val="6"/>
+                <c:pt idx="0">
+                  <c:v>0.08185386949783308</c:v>
+                </c:pt>
+                <c:pt idx="1">
+                  <c:v>0.26456876456876455</c:v>
+                </c:pt>
+                <c:pt idx="2">
+                  <c:v>0.04301468100940392</c:v>
+                </c:pt>
+                <c:pt idx="3">
+                  <c:v>0.1949308755760369</c:v>
+                </c:pt>
+                <c:pt idx="4">
+                  <c:v>0.04795587419451197</c:v>
+                </c:pt>
+                <c:pt idx="5">
+                  <c:v>0.23212560386473435</c:v>
+                </c:pt>
+              </c:numCache>
+            </c:numRef>
+          </c:val>
+        </c:ser>
+        <c:dLbls>
+          <c:numFmt formatCode="0.00" sourceLinked="0"/>
+          <c:txPr>
+            <a:bodyPr/>
+            <a:lstStyle/>
+            <a:p>
+              <a:pPr>
+                <a:defRPr sz="1100"/>
+              </a:pPr>
+            </a:p>
+          </c:txPr>
+          <c:dLblPos val="outEnd"/>
+          <c:showLegendKey val="0"/>
+          <c:showVal val="1"/>
+          <c:showCatName val="0"/>
+          <c:showSerName val="0"/>
+          <c:showPercent val="0"/>
+          <c:showBubbleSize val="0"/>
+          <c:showLeaderLines val="1"/>
+        </c:dLbls>
+        <c:axId val="-2068027336"/>
+        <c:axId val="-2113994440"/>
+      </c:barChart>
+      <c:catAx>
+        <c:axId val="-2068027336"/>
+        <c:scaling>
+          <c:orientation val="minMax"/>
+        </c:scaling>
+        <c:delete val="0"/>
+        <c:axPos val="b"/>
+        <c:majorTickMark val="out"/>
+        <c:minorTickMark val="none"/>
+        <c:tickLblPos val="nextTo"/>
+        <c:txPr>
+          <a:bodyPr/>
+          <a:lstStyle/>
+          <a:p>
+            <a:pPr>
+              <a:defRPr sz="1100"/>
+            </a:pPr>
+          </a:p>
+        </c:txPr>
+        <c:crossAx val="-2113994440"/>
+        <c:crosses val="autoZero"/>
+        <c:auto val="1"/>
+        <c:lblAlgn val="ctr"/>
+        <c:lblOffset val="100"/>
+        <c:noMultiLvlLbl val="0"/>
+      </c:catAx>
+      <c:valAx>
+        <c:axId val="-2113994440"/>
+        <c:scaling>
+          <c:min val="0.0"/>
+        </c:scaling>
+        <c:delete val="0"/>
+        <c:axPos val="l"/>
+        <c:majorTickMark val="out"/>
+        <c:minorTickMark val="none"/>
+        <c:tickLblPos val="nextTo"/>
+        <c:txPr>
+          <a:bodyPr/>
+          <a:lstStyle/>
+          <a:p>
+            <a:pPr>
+              <a:defRPr sz="1100"/>
+            </a:pPr>
+          </a:p>
+        </c:txPr>
+        <c:crossAx val="-2068027336"/>
+        <c:crosses val="autoZero"/>
+      </c:valAx>
+    </c:plotArea>
+    <c:dispBlanksAs val="gap"/>
+  </c:chart>
+  <c:txPr>
+    <a:bodyPr/>
+    <a:lstStyle/>
+    <a:p>
+      <a:pPr>
+        <a:defRPr sz="1800"/>
+      </a:pPr>
+      <a:endParaRPr lang="en-US"/>
+    </a:p>
+  </c:txPr>
+  <c:externalData r:id="rId1">
+    <c:autoUpdate val="0"/>
+  </c:externalData>
+</c:chartSpace>
+</file>
+
 <file path=ppt/charts/chart2.xml><?xml version="1.0" encoding="utf-8"?>
 <c:chartSpace xmlns:c="http://schemas.openxmlformats.org/drawingml/2006/chart" xmlns:a="http://schemas.openxmlformats.org/drawingml/2006/main" xmlns:r="http://schemas.openxmlformats.org/officeDocument/2006/relationships">
   <c:date1904 val="0"/>
@@ -1451,7 +1641,7 @@
           <a:p>
             <a:r>
               <a:rPr sz="1400"/>
-              <a:t>Difference in true-positive rate between groups (High tier)</a:t>
+              <a:t>Claude tiers on the same tasks</a:t>
             </a:r>
           </a:p>
         </c:rich>
@@ -1473,65 +1663,102 @@
               <c:strCache>
                 <c:ptCount val="1"/>
                 <c:pt idx="0">
-                  <c:v>Equal-opportunity gap</c:v>
+                  <c:v>Search filter F1</c:v>
                 </c:pt>
               </c:strCache>
             </c:strRef>
           </c:tx>
           <c:spPr>
             <a:solidFill>
-              <a:srgbClr val="B45309"/>
+              <a:srgbClr val="1F2A44"/>
             </a:solidFill>
           </c:spPr>
           <c:cat>
             <c:strRef>
-              <c:f>Sheet1!$A$2:$A$7</c:f>
+              <c:f>Sheet1!$A$2:$A$4</c:f>
               <c:strCache>
-                <c:ptCount val="6"/>
+                <c:ptCount val="3"/>
                 <c:pt idx="0">
-                  <c:v>gender</c:v>
+                  <c:v>haiku</c:v>
                 </c:pt>
                 <c:pt idx="1">
-                  <c:v>region</c:v>
+                  <c:v>sonnet</c:v>
                 </c:pt>
                 <c:pt idx="2">
-                  <c:v>highest_education</c:v>
-                </c:pt>
-                <c:pt idx="3">
-                  <c:v>imd_band</c:v>
-                </c:pt>
-                <c:pt idx="4">
-                  <c:v>age_band</c:v>
-                </c:pt>
-                <c:pt idx="5">
-                  <c:v>disability</c:v>
+                  <c:v>opus</c:v>
                 </c:pt>
               </c:strCache>
             </c:strRef>
           </c:cat>
           <c:val>
             <c:numRef>
-              <c:f>Sheet1!$B$2:$B$7</c:f>
+              <c:f>Sheet1!$B$2:$B$4</c:f>
               <c:numCache>
                 <c:formatCode>General</c:formatCode>
-                <c:ptCount val="6"/>
+                <c:ptCount val="3"/>
                 <c:pt idx="0">
-                  <c:v>0.08185386949783308</c:v>
+                  <c:v>0.8903</c:v>
                 </c:pt>
                 <c:pt idx="1">
-                  <c:v>0.26456876456876455</c:v>
+                  <c:v>0.8774</c:v>
                 </c:pt>
                 <c:pt idx="2">
-                  <c:v>0.04301468100940392</c:v>
-                </c:pt>
-                <c:pt idx="3">
-                  <c:v>0.1949308755760369</c:v>
-                </c:pt>
-                <c:pt idx="4">
-                  <c:v>0.04795587419451197</c:v>
-                </c:pt>
-                <c:pt idx="5">
-                  <c:v>0.23212560386473435</c:v>
+                  <c:v>0.8758</c:v>
+                </c:pt>
+              </c:numCache>
+            </c:numRef>
+          </c:val>
+        </c:ser>
+        <c:ser>
+          <c:idx val="1"/>
+          <c:order val="1"/>
+          <c:tx>
+            <c:strRef>
+              <c:f>Sheet1!$C$1</c:f>
+              <c:strCache>
+                <c:ptCount val="1"/>
+                <c:pt idx="0">
+                  <c:v>Synthesis judge pass</c:v>
+                </c:pt>
+              </c:strCache>
+            </c:strRef>
+          </c:tx>
+          <c:spPr>
+            <a:solidFill>
+              <a:srgbClr val="4C4BC2"/>
+            </a:solidFill>
+          </c:spPr>
+          <c:cat>
+            <c:strRef>
+              <c:f>Sheet1!$A$2:$A$4</c:f>
+              <c:strCache>
+                <c:ptCount val="3"/>
+                <c:pt idx="0">
+                  <c:v>haiku</c:v>
+                </c:pt>
+                <c:pt idx="1">
+                  <c:v>sonnet</c:v>
+                </c:pt>
+                <c:pt idx="2">
+                  <c:v>opus</c:v>
+                </c:pt>
+              </c:strCache>
+            </c:strRef>
+          </c:cat>
+          <c:val>
+            <c:numRef>
+              <c:f>Sheet1!$C$2:$C$4</c:f>
+              <c:numCache>
+                <c:formatCode>General</c:formatCode>
+                <c:ptCount val="3"/>
+                <c:pt idx="0">
+                  <c:v>0.375</c:v>
+                </c:pt>
+                <c:pt idx="1">
+                  <c:v>1.0</c:v>
+                </c:pt>
+                <c:pt idx="2">
+                  <c:v>0.7</c:v>
                 </c:pt>
               </c:numCache>
             </c:numRef>
@@ -1589,6 +1816,7 @@
       <c:valAx>
         <c:axId val="-2113994440"/>
         <c:scaling>
+          <c:max val="1.0"/>
           <c:min val="0.0"/>
         </c:scaling>
         <c:delete val="0"/>
@@ -1609,6 +1837,473 @@
         <c:crosses val="autoZero"/>
       </c:valAx>
     </c:plotArea>
+    <c:legend/>
+    <c:dispBlanksAs val="gap"/>
+  </c:chart>
+  <c:txPr>
+    <a:bodyPr/>
+    <a:lstStyle/>
+    <a:p>
+      <a:pPr>
+        <a:defRPr sz="1800"/>
+      </a:pPr>
+      <a:endParaRPr lang="en-US"/>
+    </a:p>
+  </c:txPr>
+  <c:externalData r:id="rId1">
+    <c:autoUpdate val="0"/>
+  </c:externalData>
+</c:chartSpace>
+</file>
+
+<file path=ppt/charts/chart8.xml><?xml version="1.0" encoding="utf-8"?>
+<c:chartSpace xmlns:c="http://schemas.openxmlformats.org/drawingml/2006/chart" xmlns:a="http://schemas.openxmlformats.org/drawingml/2006/main" xmlns:r="http://schemas.openxmlformats.org/officeDocument/2006/relationships">
+  <c:date1904 val="0"/>
+  <c:chart>
+    <c:title>
+      <c:tx>
+        <c:rich>
+          <a:bodyPr/>
+          <a:lstStyle/>
+          <a:p>
+            <a:r>
+              <a:rPr sz="1400"/>
+              <a:t>Embedding models on the same narratives</a:t>
+            </a:r>
+          </a:p>
+        </c:rich>
+      </c:tx>
+      <c:layout/>
+      <c:overlay val="0"/>
+    </c:title>
+    <c:autoTitleDeleted val="0"/>
+    <c:plotArea>
+      <c:barChart>
+        <c:barDir val="col"/>
+        <c:grouping val="clustered"/>
+        <c:ser>
+          <c:idx val="0"/>
+          <c:order val="0"/>
+          <c:tx>
+            <c:strRef>
+              <c:f>Sheet1!$B$1</c:f>
+              <c:strCache>
+                <c:ptCount val="1"/>
+                <c:pt idx="0">
+                  <c:v>Typed search P@10 (dense)</c:v>
+                </c:pt>
+              </c:strCache>
+            </c:strRef>
+          </c:tx>
+          <c:spPr>
+            <a:solidFill>
+              <a:srgbClr val="0F766E"/>
+            </a:solidFill>
+          </c:spPr>
+          <c:cat>
+            <c:strRef>
+              <c:f>Sheet1!$A$2:$A$6</c:f>
+              <c:strCache>
+                <c:ptCount val="5"/>
+                <c:pt idx="0">
+                  <c:v>MiniLM-L6-v2</c:v>
+                </c:pt>
+                <c:pt idx="1">
+                  <c:v>mpnet-base-v2</c:v>
+                </c:pt>
+                <c:pt idx="2">
+                  <c:v>bge-small</c:v>
+                </c:pt>
+                <c:pt idx="3">
+                  <c:v>e5-smv2</c:v>
+                </c:pt>
+                <c:pt idx="4">
+                  <c:v>gte-small</c:v>
+                </c:pt>
+              </c:strCache>
+            </c:strRef>
+          </c:cat>
+          <c:val>
+            <c:numRef>
+              <c:f>Sheet1!$B$2:$B$6</c:f>
+              <c:numCache>
+                <c:formatCode>General</c:formatCode>
+                <c:ptCount val="5"/>
+                <c:pt idx="0">
+                  <c:v>0.714375</c:v>
+                </c:pt>
+                <c:pt idx="1">
+                  <c:v>0.6693749999999999</c:v>
+                </c:pt>
+                <c:pt idx="2">
+                  <c:v>0.771875</c:v>
+                </c:pt>
+                <c:pt idx="3">
+                  <c:v>0.8018750000000001</c:v>
+                </c:pt>
+                <c:pt idx="4">
+                  <c:v>0.806875</c:v>
+                </c:pt>
+              </c:numCache>
+            </c:numRef>
+          </c:val>
+        </c:ser>
+        <c:ser>
+          <c:idx val="1"/>
+          <c:order val="1"/>
+          <c:tx>
+            <c:strRef>
+              <c:f>Sheet1!$C$1</c:f>
+              <c:strCache>
+                <c:ptCount val="1"/>
+                <c:pt idx="0">
+                  <c:v>Precedent vote-AUC (dense)</c:v>
+                </c:pt>
+              </c:strCache>
+            </c:strRef>
+          </c:tx>
+          <c:spPr>
+            <a:solidFill>
+              <a:srgbClr val="64748B"/>
+            </a:solidFill>
+          </c:spPr>
+          <c:cat>
+            <c:strRef>
+              <c:f>Sheet1!$A$2:$A$6</c:f>
+              <c:strCache>
+                <c:ptCount val="5"/>
+                <c:pt idx="0">
+                  <c:v>MiniLM-L6-v2</c:v>
+                </c:pt>
+                <c:pt idx="1">
+                  <c:v>mpnet-base-v2</c:v>
+                </c:pt>
+                <c:pt idx="2">
+                  <c:v>bge-small</c:v>
+                </c:pt>
+                <c:pt idx="3">
+                  <c:v>e5-smv2</c:v>
+                </c:pt>
+                <c:pt idx="4">
+                  <c:v>gte-small</c:v>
+                </c:pt>
+              </c:strCache>
+            </c:strRef>
+          </c:cat>
+          <c:val>
+            <c:numRef>
+              <c:f>Sheet1!$C$2:$C$6</c:f>
+              <c:numCache>
+                <c:formatCode>General</c:formatCode>
+                <c:ptCount val="5"/>
+                <c:pt idx="0">
+                  <c:v>0.7496673402000888</c:v>
+                </c:pt>
+                <c:pt idx="1">
+                  <c:v>0.7301512986052929</c:v>
+                </c:pt>
+                <c:pt idx="2">
+                  <c:v>0.7771918584594155</c:v>
+                </c:pt>
+                <c:pt idx="3">
+                  <c:v>0.8315016509782662</c:v>
+                </c:pt>
+                <c:pt idx="4">
+                  <c:v>0.7691833817948843</c:v>
+                </c:pt>
+              </c:numCache>
+            </c:numRef>
+          </c:val>
+        </c:ser>
+        <c:dLbls>
+          <c:numFmt formatCode="0.00" sourceLinked="0"/>
+          <c:txPr>
+            <a:bodyPr/>
+            <a:lstStyle/>
+            <a:p>
+              <a:pPr>
+                <a:defRPr sz="1100"/>
+              </a:pPr>
+            </a:p>
+          </c:txPr>
+          <c:dLblPos val="outEnd"/>
+          <c:showLegendKey val="0"/>
+          <c:showVal val="1"/>
+          <c:showCatName val="0"/>
+          <c:showSerName val="0"/>
+          <c:showPercent val="0"/>
+          <c:showBubbleSize val="0"/>
+          <c:showLeaderLines val="1"/>
+        </c:dLbls>
+        <c:axId val="-2068027336"/>
+        <c:axId val="-2113994440"/>
+      </c:barChart>
+      <c:catAx>
+        <c:axId val="-2068027336"/>
+        <c:scaling>
+          <c:orientation val="minMax"/>
+        </c:scaling>
+        <c:delete val="0"/>
+        <c:axPos val="b"/>
+        <c:majorTickMark val="out"/>
+        <c:minorTickMark val="none"/>
+        <c:tickLblPos val="nextTo"/>
+        <c:txPr>
+          <a:bodyPr/>
+          <a:lstStyle/>
+          <a:p>
+            <a:pPr>
+              <a:defRPr sz="1100"/>
+            </a:pPr>
+          </a:p>
+        </c:txPr>
+        <c:crossAx val="-2113994440"/>
+        <c:crosses val="autoZero"/>
+        <c:auto val="1"/>
+        <c:lblAlgn val="ctr"/>
+        <c:lblOffset val="100"/>
+        <c:noMultiLvlLbl val="0"/>
+      </c:catAx>
+      <c:valAx>
+        <c:axId val="-2113994440"/>
+        <c:scaling>
+          <c:max val="1.0"/>
+          <c:min val="0.0"/>
+        </c:scaling>
+        <c:delete val="0"/>
+        <c:axPos val="l"/>
+        <c:majorTickMark val="out"/>
+        <c:minorTickMark val="none"/>
+        <c:tickLblPos val="nextTo"/>
+        <c:txPr>
+          <a:bodyPr/>
+          <a:lstStyle/>
+          <a:p>
+            <a:pPr>
+              <a:defRPr sz="1100"/>
+            </a:pPr>
+          </a:p>
+        </c:txPr>
+        <c:crossAx val="-2068027336"/>
+        <c:crosses val="autoZero"/>
+      </c:valAx>
+    </c:plotArea>
+    <c:legend/>
+    <c:dispBlanksAs val="gap"/>
+  </c:chart>
+  <c:txPr>
+    <a:bodyPr/>
+    <a:lstStyle/>
+    <a:p>
+      <a:pPr>
+        <a:defRPr sz="1800"/>
+      </a:pPr>
+      <a:endParaRPr lang="en-US"/>
+    </a:p>
+  </c:txPr>
+  <c:externalData r:id="rId1">
+    <c:autoUpdate val="0"/>
+  </c:externalData>
+</c:chartSpace>
+</file>
+
+<file path=ppt/charts/chart9.xml><?xml version="1.0" encoding="utf-8"?>
+<c:chartSpace xmlns:c="http://schemas.openxmlformats.org/drawingml/2006/chart" xmlns:a="http://schemas.openxmlformats.org/drawingml/2006/main" xmlns:r="http://schemas.openxmlformats.org/officeDocument/2006/relationships">
+  <c:date1904 val="0"/>
+  <c:chart>
+    <c:title>
+      <c:tx>
+        <c:rich>
+          <a:bodyPr/>
+          <a:lstStyle/>
+          <a:p>
+            <a:r>
+              <a:rPr sz="1400"/>
+              <a:t>RAGAS on the retrieval-augmented features</a:t>
+            </a:r>
+          </a:p>
+        </c:rich>
+      </c:tx>
+      <c:layout/>
+      <c:overlay val="0"/>
+    </c:title>
+    <c:autoTitleDeleted val="0"/>
+    <c:plotArea>
+      <c:barChart>
+        <c:barDir val="col"/>
+        <c:grouping val="clustered"/>
+        <c:ser>
+          <c:idx val="0"/>
+          <c:order val="0"/>
+          <c:tx>
+            <c:strRef>
+              <c:f>Sheet1!$B$1</c:f>
+              <c:strCache>
+                <c:ptCount val="1"/>
+                <c:pt idx="0">
+                  <c:v>RAGAS faithfulness</c:v>
+                </c:pt>
+              </c:strCache>
+            </c:strRef>
+          </c:tx>
+          <c:spPr>
+            <a:solidFill>
+              <a:srgbClr val="1F2A44"/>
+            </a:solidFill>
+          </c:spPr>
+          <c:cat>
+            <c:strRef>
+              <c:f>Sheet1!$A$2:$A$3</c:f>
+              <c:strCache>
+                <c:ptCount val="2"/>
+                <c:pt idx="0">
+                  <c:v>copilot</c:v>
+                </c:pt>
+                <c:pt idx="1">
+                  <c:v>precedent_synthesis</c:v>
+                </c:pt>
+              </c:strCache>
+            </c:strRef>
+          </c:cat>
+          <c:val>
+            <c:numRef>
+              <c:f>Sheet1!$B$2:$B$3</c:f>
+              <c:numCache>
+                <c:formatCode>General</c:formatCode>
+                <c:ptCount val="2"/>
+                <c:pt idx="0">
+                  <c:v>0.8335</c:v>
+                </c:pt>
+                <c:pt idx="1">
+                  <c:v>0.9644</c:v>
+                </c:pt>
+              </c:numCache>
+            </c:numRef>
+          </c:val>
+        </c:ser>
+        <c:ser>
+          <c:idx val="1"/>
+          <c:order val="1"/>
+          <c:tx>
+            <c:strRef>
+              <c:f>Sheet1!$C$1</c:f>
+              <c:strCache>
+                <c:ptCount val="1"/>
+                <c:pt idx="0">
+                  <c:v>Context relevance</c:v>
+                </c:pt>
+              </c:strCache>
+            </c:strRef>
+          </c:tx>
+          <c:spPr>
+            <a:solidFill>
+              <a:srgbClr val="0F766E"/>
+            </a:solidFill>
+          </c:spPr>
+          <c:cat>
+            <c:strRef>
+              <c:f>Sheet1!$A$2:$A$3</c:f>
+              <c:strCache>
+                <c:ptCount val="2"/>
+                <c:pt idx="0">
+                  <c:v>copilot</c:v>
+                </c:pt>
+                <c:pt idx="1">
+                  <c:v>precedent_synthesis</c:v>
+                </c:pt>
+              </c:strCache>
+            </c:strRef>
+          </c:cat>
+          <c:val>
+            <c:numRef>
+              <c:f>Sheet1!$C$2:$C$3</c:f>
+              <c:numCache>
+                <c:formatCode>General</c:formatCode>
+                <c:ptCount val="2"/>
+                <c:pt idx="0">
+                  <c:v>1.0</c:v>
+                </c:pt>
+                <c:pt idx="1">
+                  <c:v>1.0</c:v>
+                </c:pt>
+              </c:numCache>
+            </c:numRef>
+          </c:val>
+        </c:ser>
+        <c:dLbls>
+          <c:numFmt formatCode="0.00" sourceLinked="0"/>
+          <c:txPr>
+            <a:bodyPr/>
+            <a:lstStyle/>
+            <a:p>
+              <a:pPr>
+                <a:defRPr sz="1100"/>
+              </a:pPr>
+            </a:p>
+          </c:txPr>
+          <c:dLblPos val="outEnd"/>
+          <c:showLegendKey val="0"/>
+          <c:showVal val="1"/>
+          <c:showCatName val="0"/>
+          <c:showSerName val="0"/>
+          <c:showPercent val="0"/>
+          <c:showBubbleSize val="0"/>
+          <c:showLeaderLines val="1"/>
+        </c:dLbls>
+        <c:axId val="-2068027336"/>
+        <c:axId val="-2113994440"/>
+      </c:barChart>
+      <c:catAx>
+        <c:axId val="-2068027336"/>
+        <c:scaling>
+          <c:orientation val="minMax"/>
+        </c:scaling>
+        <c:delete val="0"/>
+        <c:axPos val="b"/>
+        <c:majorTickMark val="out"/>
+        <c:minorTickMark val="none"/>
+        <c:tickLblPos val="nextTo"/>
+        <c:txPr>
+          <a:bodyPr/>
+          <a:lstStyle/>
+          <a:p>
+            <a:pPr>
+              <a:defRPr sz="1100"/>
+            </a:pPr>
+          </a:p>
+        </c:txPr>
+        <c:crossAx val="-2113994440"/>
+        <c:crosses val="autoZero"/>
+        <c:auto val="1"/>
+        <c:lblAlgn val="ctr"/>
+        <c:lblOffset val="100"/>
+        <c:noMultiLvlLbl val="0"/>
+      </c:catAx>
+      <c:valAx>
+        <c:axId val="-2113994440"/>
+        <c:scaling>
+          <c:max val="1.0"/>
+          <c:min val="0.0"/>
+        </c:scaling>
+        <c:delete val="0"/>
+        <c:axPos val="l"/>
+        <c:majorTickMark val="out"/>
+        <c:minorTickMark val="none"/>
+        <c:tickLblPos val="nextTo"/>
+        <c:txPr>
+          <a:bodyPr/>
+          <a:lstStyle/>
+          <a:p>
+            <a:pPr>
+              <a:defRPr sz="1100"/>
+            </a:pPr>
+          </a:p>
+        </c:txPr>
+        <c:crossAx val="-2068027336"/>
+        <c:crosses val="autoZero"/>
+      </c:valAx>
+    </c:plotArea>
+    <c:legend/>
     <c:dispBlanksAs val="gap"/>
   </c:chart>
   <c:txPr>
@@ -2232,7 +2927,7 @@
           <a:lstStyle/>
           <a:p>
             <a:r>
-              <a:t>Gaps remain via proxies; they are flagged by the gate and need institutional review.</a:t>
+              <a:t>The same features ran on Haiku, Sonnet and Opus with identical prompts and checks; five embedding models encoded the same case narratives. Production choices follow the measurements.</a:t>
             </a:r>
           </a:p>
         </p:txBody>
@@ -2302,6 +2997,146 @@
           <a:lstStyle/>
           <a:p>
             <a:r>
+              <a:t>Code checks on every output; LLM-as-judge with anchored rubrics and order-swapped A/B; DeepEval; RAGAS on the retrieval-augmented features; blind human review in the console to check the judge.</a:t>
+            </a:r>
+          </a:p>
+        </p:txBody>
+      </p:sp>
+      <p:sp>
+        <p:nvSpPr>
+          <p:cNvPr id="4" name="Slide Number Placeholder 3"/>
+          <p:cNvSpPr>
+            <a:spLocks noGrp="1"/>
+          </p:cNvSpPr>
+          <p:nvPr>
+            <p:ph type="sldNum" idx="5" sz="quarter"/>
+          </p:nvPr>
+        </p:nvSpPr>
+        <p:spPr/>
+      </p:sp>
+    </p:spTree>
+  </p:cSld>
+  <p:clrMapOvr>
+    <a:masterClrMapping/>
+  </p:clrMapOvr>
+</p:notes>
+</file>
+
+<file path=ppt/notesSlides/notesSlide14.xml><?xml version="1.0" encoding="utf-8"?>
+<p:notes xmlns:a="http://schemas.openxmlformats.org/drawingml/2006/main" xmlns:p="http://schemas.openxmlformats.org/presentationml/2006/main" xmlns:r="http://schemas.openxmlformats.org/officeDocument/2006/relationships">
+  <p:cSld>
+    <p:spTree>
+      <p:nvGrpSpPr>
+        <p:cNvPr id="1" name=""/>
+        <p:cNvGrpSpPr/>
+        <p:nvPr/>
+      </p:nvGrpSpPr>
+      <p:grpSpPr>
+        <a:xfrm>
+          <a:off x="0" y="0"/>
+          <a:ext cx="0" cy="0"/>
+          <a:chOff x="0" y="0"/>
+          <a:chExt cx="0" cy="0"/>
+        </a:xfrm>
+      </p:grpSpPr>
+      <p:sp>
+        <p:nvSpPr>
+          <p:cNvPr id="2" name="Slide Image Placeholder 1"/>
+          <p:cNvSpPr>
+            <a:spLocks noGrp="1"/>
+          </p:cNvSpPr>
+          <p:nvPr>
+            <p:ph type="sldImg" idx="2"/>
+          </p:nvPr>
+        </p:nvSpPr>
+        <p:spPr/>
+      </p:sp>
+      <p:sp>
+        <p:nvSpPr>
+          <p:cNvPr id="3" name="Notes Placeholder 2"/>
+          <p:cNvSpPr>
+            <a:spLocks noGrp="1"/>
+          </p:cNvSpPr>
+          <p:nvPr>
+            <p:ph type="body" idx="3" sz="quarter"/>
+          </p:nvPr>
+        </p:nvSpPr>
+        <p:spPr/>
+        <p:txBody>
+          <a:bodyPr/>
+          <a:lstStyle/>
+          <a:p>
+            <a:r>
+              <a:t>Gaps remain via proxies; they are flagged by the gate and need institutional review.</a:t>
+            </a:r>
+          </a:p>
+        </p:txBody>
+      </p:sp>
+      <p:sp>
+        <p:nvSpPr>
+          <p:cNvPr id="4" name="Slide Number Placeholder 3"/>
+          <p:cNvSpPr>
+            <a:spLocks noGrp="1"/>
+          </p:cNvSpPr>
+          <p:nvPr>
+            <p:ph type="sldNum" idx="5" sz="quarter"/>
+          </p:nvPr>
+        </p:nvSpPr>
+        <p:spPr/>
+      </p:sp>
+    </p:spTree>
+  </p:cSld>
+  <p:clrMapOvr>
+    <a:masterClrMapping/>
+  </p:clrMapOvr>
+</p:notes>
+</file>
+
+<file path=ppt/notesSlides/notesSlide15.xml><?xml version="1.0" encoding="utf-8"?>
+<p:notes xmlns:a="http://schemas.openxmlformats.org/drawingml/2006/main" xmlns:p="http://schemas.openxmlformats.org/presentationml/2006/main" xmlns:r="http://schemas.openxmlformats.org/officeDocument/2006/relationships">
+  <p:cSld>
+    <p:spTree>
+      <p:nvGrpSpPr>
+        <p:cNvPr id="1" name=""/>
+        <p:cNvGrpSpPr/>
+        <p:nvPr/>
+      </p:nvGrpSpPr>
+      <p:grpSpPr>
+        <a:xfrm>
+          <a:off x="0" y="0"/>
+          <a:ext cx="0" cy="0"/>
+          <a:chOff x="0" y="0"/>
+          <a:chExt cx="0" cy="0"/>
+        </a:xfrm>
+      </p:grpSpPr>
+      <p:sp>
+        <p:nvSpPr>
+          <p:cNvPr id="2" name="Slide Image Placeholder 1"/>
+          <p:cNvSpPr>
+            <a:spLocks noGrp="1"/>
+          </p:cNvSpPr>
+          <p:nvPr>
+            <p:ph type="sldImg" idx="2"/>
+          </p:nvPr>
+        </p:nvSpPr>
+        <p:spPr/>
+      </p:sp>
+      <p:sp>
+        <p:nvSpPr>
+          <p:cNvPr id="3" name="Notes Placeholder 2"/>
+          <p:cNvSpPr>
+            <a:spLocks noGrp="1"/>
+          </p:cNvSpPr>
+          <p:nvPr>
+            <p:ph type="body" idx="3" sz="quarter"/>
+          </p:nvPr>
+        </p:nvSpPr>
+        <p:spPr/>
+        <p:txBody>
+          <a:bodyPr/>
+          <a:lstStyle/>
+          <a:p>
+            <a:r>
               <a:t>Feedback becomes versioned, human-approved changes; then re-evaluate.</a:t>
             </a:r>
           </a:p>
@@ -2792,7 +3627,7 @@
           <a:lstStyle/>
           <a:p>
             <a:r>
-              <a:t>Behavioural kNN weighted by model attributions + BM25 over qualitative descriptors (+ optional dense). Only earlier presentations are searchable. Evaluated against real outcomes and a random baseline.</a:t>
+              <a:t>Behavioural kNN weighted by model attributions + BM25 over qualitative descriptors + dense narrative embeddings, fused with RRF; vectors live in LanceDB with metadata filters pushed down. Only earlier presentations are searchable. Evaluated against real outcomes and a random baseline.</a:t>
             </a:r>
           </a:p>
         </p:txBody>
@@ -6054,7 +6889,7 @@
                   <a:srgbClr val="1F2A44"/>
                 </a:solidFill>
               </a:rPr>
-              <a:t>Performance → Risk → Router → Intervention ⇄ Critic, or Monitoring for low-risk students.</a:t>
+              <a:t>A LangGraph state graph: Performance → Risk → Router → Intervention ⇄ Critic, or a deterministic plan.</a:t>
             </a:r>
           </a:p>
           <a:p>
@@ -6491,6 +7326,382 @@
                   <a:srgbClr val="1F2A44"/>
                 </a:solidFill>
               </a:rPr>
+              <a:t>Choosing the models: measured, not assumed</a:t>
+            </a:r>
+          </a:p>
+        </p:txBody>
+      </p:sp>
+      <p:graphicFrame>
+        <p:nvGraphicFramePr>
+          <p:cNvPr id="3" name="Chart 2"/>
+          <p:cNvGraphicFramePr>
+            <a:graphicFrameLocks noGrp="1"/>
+          </p:cNvGraphicFramePr>
+          <p:nvPr/>
+        </p:nvGraphicFramePr>
+        <p:xfrm>
+          <a:off x="548640" y="1280160"/>
+          <a:ext cx="5486400" cy="2468880"/>
+        </p:xfrm>
+        <a:graphic>
+          <a:graphicData uri="http://schemas.openxmlformats.org/drawingml/2006/chart">
+            <c:chart xmlns:c="http://schemas.openxmlformats.org/drawingml/2006/chart" r:id="rId3"/>
+          </a:graphicData>
+        </a:graphic>
+      </p:graphicFrame>
+      <p:sp>
+        <p:nvSpPr>
+          <p:cNvPr id="4" name="TextBox 3"/>
+          <p:cNvSpPr txBox="1"/>
+          <p:nvPr/>
+        </p:nvSpPr>
+        <p:spPr>
+          <a:xfrm>
+            <a:off x="6309360" y="1371600"/>
+            <a:ext cx="5486400" cy="2560320"/>
+          </a:xfrm>
+          <a:prstGeom prst="rect">
+            <a:avLst/>
+          </a:prstGeom>
+          <a:noFill/>
+        </p:spPr>
+        <p:txBody>
+          <a:bodyPr wrap="square">
+            <a:spAutoFit/>
+          </a:bodyPr>
+          <a:lstStyle/>
+          <a:p>
+            <a:pPr>
+              <a:spcAft>
+                <a:spcPts val="800"/>
+              </a:spcAft>
+            </a:pPr>
+            <a:r>
+              <a:rPr sz="1300" b="0">
+                <a:solidFill>
+                  <a:srgbClr val="1F2A44"/>
+                </a:solidFill>
+              </a:rPr>
+              <a:t>Cost per call: haiku $0.0003 (search) / $0.0008 (synthesis), sonnet $0.0053 (search) / $0.0095 (synthesis), opus $0.0109 (search) / $0.0208 (synthesis)</a:t>
+            </a:r>
+          </a:p>
+          <a:p>
+            <a:pPr>
+              <a:spcAft>
+                <a:spcPts val="800"/>
+              </a:spcAft>
+            </a:pPr>
+            <a:r>
+              <a:rPr sz="1300" b="0">
+                <a:solidFill>
+                  <a:srgbClr val="1F2A44"/>
+                </a:solidFill>
+              </a:rPr>
+              <a:t>Production: claude-haiku-5-5 parses, claude-sonnet-5-5 writes, claude-opus-5-5 judges (never its own output).</a:t>
+            </a:r>
+          </a:p>
+        </p:txBody>
+      </p:sp>
+      <p:graphicFrame>
+        <p:nvGraphicFramePr>
+          <p:cNvPr id="5" name="Chart 4"/>
+          <p:cNvGraphicFramePr>
+            <a:graphicFrameLocks noGrp="1"/>
+          </p:cNvGraphicFramePr>
+          <p:nvPr/>
+        </p:nvGraphicFramePr>
+        <p:xfrm>
+          <a:off x="548640" y="3931920"/>
+          <a:ext cx="5486400" cy="2560320"/>
+        </p:xfrm>
+        <a:graphic>
+          <a:graphicData uri="http://schemas.openxmlformats.org/drawingml/2006/chart">
+            <c:chart xmlns:c="http://schemas.openxmlformats.org/drawingml/2006/chart" r:id="rId4"/>
+          </a:graphicData>
+        </a:graphic>
+      </p:graphicFrame>
+      <p:sp>
+        <p:nvSpPr>
+          <p:cNvPr id="6" name="TextBox 5"/>
+          <p:cNvSpPr txBox="1"/>
+          <p:nvPr/>
+        </p:nvSpPr>
+        <p:spPr>
+          <a:xfrm>
+            <a:off x="6309360" y="4023360"/>
+            <a:ext cx="5486400" cy="2560320"/>
+          </a:xfrm>
+          <a:prstGeom prst="rect">
+            <a:avLst/>
+          </a:prstGeom>
+          <a:noFill/>
+        </p:spPr>
+        <p:txBody>
+          <a:bodyPr wrap="square">
+            <a:spAutoFit/>
+          </a:bodyPr>
+          <a:lstStyle/>
+          <a:p>
+            <a:pPr>
+              <a:spcAft>
+                <a:spcPts val="800"/>
+              </a:spcAft>
+            </a:pPr>
+            <a:r>
+              <a:rPr sz="1300" b="0">
+                <a:solidFill>
+                  <a:srgbClr val="1F2A44"/>
+                </a:solidFill>
+              </a:rPr>
+              <a:t>Encoding speed 9–77 docs/s on CPU; index 37–74 MB.</a:t>
+            </a:r>
+          </a:p>
+          <a:p>
+            <a:pPr>
+              <a:spcAft>
+                <a:spcPts val="800"/>
+              </a:spcAft>
+            </a:pPr>
+            <a:r>
+              <a:rPr sz="1300" b="0">
+                <a:solidFill>
+                  <a:srgbClr val="1F2A44"/>
+                </a:solidFill>
+              </a:rPr>
+              <a:t>In use: all-MiniLM-L6-v2 (full table in the model card).</a:t>
+            </a:r>
+          </a:p>
+        </p:txBody>
+      </p:sp>
+    </p:spTree>
+  </p:cSld>
+  <p:clrMapOvr>
+    <a:masterClrMapping/>
+  </p:clrMapOvr>
+</p:sld>
+</file>
+
+<file path=ppt/slides/slide13.xml><?xml version="1.0" encoding="utf-8"?>
+<p:sld xmlns:a="http://schemas.openxmlformats.org/drawingml/2006/main" xmlns:p="http://schemas.openxmlformats.org/presentationml/2006/main" xmlns:r="http://schemas.openxmlformats.org/officeDocument/2006/relationships">
+  <p:cSld>
+    <p:bg>
+      <p:bgPr>
+        <a:solidFill>
+          <a:srgbClr val="FBFBF9"/>
+        </a:solidFill>
+        <a:effectLst/>
+      </p:bgPr>
+    </p:bg>
+    <p:spTree>
+      <p:nvGrpSpPr>
+        <p:cNvPr id="1" name=""/>
+        <p:cNvGrpSpPr/>
+        <p:nvPr/>
+      </p:nvGrpSpPr>
+      <p:grpSpPr/>
+      <p:sp>
+        <p:nvSpPr>
+          <p:cNvPr id="2" name="TextBox 1"/>
+          <p:cNvSpPr txBox="1"/>
+          <p:nvPr/>
+        </p:nvSpPr>
+        <p:spPr>
+          <a:xfrm>
+            <a:off x="548640" y="365760"/>
+            <a:ext cx="10972800" cy="914400"/>
+          </a:xfrm>
+          <a:prstGeom prst="rect">
+            <a:avLst/>
+          </a:prstGeom>
+          <a:noFill/>
+        </p:spPr>
+        <p:txBody>
+          <a:bodyPr wrap="square">
+            <a:spAutoFit/>
+          </a:bodyPr>
+          <a:lstStyle/>
+          <a:p>
+            <a:r>
+              <a:rPr sz="3000" b="1">
+                <a:solidFill>
+                  <a:srgbClr val="1F2A44"/>
+                </a:solidFill>
+              </a:rPr>
+              <a:t>Evaluating the AI: five layers</a:t>
+            </a:r>
+          </a:p>
+        </p:txBody>
+      </p:sp>
+      <p:graphicFrame>
+        <p:nvGraphicFramePr>
+          <p:cNvPr id="3" name="Chart 2"/>
+          <p:cNvGraphicFramePr>
+            <a:graphicFrameLocks noGrp="1"/>
+          </p:cNvGraphicFramePr>
+          <p:nvPr/>
+        </p:nvGraphicFramePr>
+        <p:xfrm>
+          <a:off x="548640" y="1280160"/>
+          <a:ext cx="5852160" cy="4937760"/>
+        </p:xfrm>
+        <a:graphic>
+          <a:graphicData uri="http://schemas.openxmlformats.org/drawingml/2006/chart">
+            <c:chart xmlns:c="http://schemas.openxmlformats.org/drawingml/2006/chart" r:id="rId3"/>
+          </a:graphicData>
+        </a:graphic>
+      </p:graphicFrame>
+      <p:sp>
+        <p:nvSpPr>
+          <p:cNvPr id="4" name="TextBox 3"/>
+          <p:cNvSpPr txBox="1"/>
+          <p:nvPr/>
+        </p:nvSpPr>
+        <p:spPr>
+          <a:xfrm>
+            <a:off x="6675120" y="1371600"/>
+            <a:ext cx="5120640" cy="5029200"/>
+          </a:xfrm>
+          <a:prstGeom prst="rect">
+            <a:avLst/>
+          </a:prstGeom>
+          <a:noFill/>
+        </p:spPr>
+        <p:txBody>
+          <a:bodyPr wrap="square">
+            <a:spAutoFit/>
+          </a:bodyPr>
+          <a:lstStyle/>
+          <a:p>
+            <a:pPr>
+              <a:spcAft>
+                <a:spcPts val="800"/>
+              </a:spcAft>
+            </a:pPr>
+            <a:r>
+              <a:rPr sz="1400" b="0">
+                <a:solidFill>
+                  <a:srgbClr val="1F2A44"/>
+                </a:solidFill>
+              </a:rPr>
+              <a:t>1. Code checks on every output: cited IDs, numbers, protected, punitive, clinical and stigma terms.</a:t>
+            </a:r>
+          </a:p>
+          <a:p>
+            <a:pPr>
+              <a:spcAft>
+                <a:spcPts val="800"/>
+              </a:spcAft>
+            </a:pPr>
+            <a:r>
+              <a:rPr sz="1400" b="0">
+                <a:solidFill>
+                  <a:srgbClr val="1F2A44"/>
+                </a:solidFill>
+              </a:rPr>
+              <a:t>2. LLM judge (separate model): 96% of plans pass; AI plan preferred in 89% of order-swapped comparisons.</a:t>
+            </a:r>
+          </a:p>
+          <a:p>
+            <a:pPr>
+              <a:spcAft>
+                <a:spcPts val="800"/>
+              </a:spcAft>
+            </a:pPr>
+            <a:r>
+              <a:rPr sz="1400" b="0">
+                <a:solidFill>
+                  <a:srgbClr val="1F2A44"/>
+                </a:solidFill>
+              </a:rPr>
+              <a:t>3. DeepEval: faithfulness, relevancy and three rubric metrics.</a:t>
+            </a:r>
+          </a:p>
+          <a:p>
+            <a:pPr>
+              <a:spcAft>
+                <a:spcPts val="800"/>
+              </a:spcAft>
+            </a:pPr>
+            <a:r>
+              <a:rPr sz="1400" b="0">
+                <a:solidFill>
+                  <a:srgbClr val="1F2A44"/>
+                </a:solidFill>
+              </a:rPr>
+              <a:t>4. RAGAS: copilot hallucination rate 16.7%; precedent_synthesis hallucination rate 3.6%.</a:t>
+            </a:r>
+          </a:p>
+          <a:p>
+            <a:pPr>
+              <a:spcAft>
+                <a:spcPts val="800"/>
+              </a:spcAft>
+            </a:pPr>
+            <a:r>
+              <a:rPr sz="1400" b="0">
+                <a:solidFill>
+                  <a:srgbClr val="1F2A44"/>
+                </a:solidFill>
+              </a:rPr>
+              <a:t>5. Human review: advisors rate plans blind in the console; agreement with the judge (Cohen's kappa) is reported.</a:t>
+            </a:r>
+          </a:p>
+        </p:txBody>
+      </p:sp>
+    </p:spTree>
+  </p:cSld>
+  <p:clrMapOvr>
+    <a:masterClrMapping/>
+  </p:clrMapOvr>
+</p:sld>
+</file>
+
+<file path=ppt/slides/slide14.xml><?xml version="1.0" encoding="utf-8"?>
+<p:sld xmlns:a="http://schemas.openxmlformats.org/drawingml/2006/main" xmlns:p="http://schemas.openxmlformats.org/presentationml/2006/main" xmlns:r="http://schemas.openxmlformats.org/officeDocument/2006/relationships">
+  <p:cSld>
+    <p:bg>
+      <p:bgPr>
+        <a:solidFill>
+          <a:srgbClr val="FBFBF9"/>
+        </a:solidFill>
+        <a:effectLst/>
+      </p:bgPr>
+    </p:bg>
+    <p:spTree>
+      <p:nvGrpSpPr>
+        <p:cNvPr id="1" name=""/>
+        <p:cNvGrpSpPr/>
+        <p:nvPr/>
+      </p:nvGrpSpPr>
+      <p:grpSpPr/>
+      <p:sp>
+        <p:nvSpPr>
+          <p:cNvPr id="2" name="TextBox 1"/>
+          <p:cNvSpPr txBox="1"/>
+          <p:nvPr/>
+        </p:nvSpPr>
+        <p:spPr>
+          <a:xfrm>
+            <a:off x="548640" y="365760"/>
+            <a:ext cx="10972800" cy="914400"/>
+          </a:xfrm>
+          <a:prstGeom prst="rect">
+            <a:avLst/>
+          </a:prstGeom>
+          <a:noFill/>
+        </p:spPr>
+        <p:txBody>
+          <a:bodyPr wrap="square">
+            <a:spAutoFit/>
+          </a:bodyPr>
+          <a:lstStyle/>
+          <a:p>
+            <a:r>
+              <a:rPr sz="3000" b="1">
+                <a:solidFill>
+                  <a:srgbClr val="1F2A44"/>
+                </a:solidFill>
+              </a:rPr>
               <a:t>Fairness and limits — stated, not hidden</a:t>
             </a:r>
           </a:p>
@@ -6542,12 +7753,12 @@
               </a:spcAft>
             </a:pPr>
             <a:r>
-              <a:rPr sz="1500" b="0">
+              <a:rPr sz="1300" b="0">
                 <a:solidFill>
                   <a:srgbClr val="1F2A44"/>
                 </a:solidFill>
               </a:rPr>
-              <a:t>Sensitive attributes are excluded from the model and from agent prompts, yet gaps persist through proxies and base-rate differences.</a:t>
+              <a:t>Sensitive attributes are excluded from the model and from agent prompts; each gap is tested against shuffled group labels, overall and within module.</a:t>
             </a:r>
           </a:p>
           <a:p>
@@ -6557,12 +7768,12 @@
               </a:spcAft>
             </a:pPr>
             <a:r>
-              <a:rPr sz="1500" b="0">
+              <a:rPr sz="1300" b="0">
                 <a:solidFill>
                   <a:srgbClr val="1F2A44"/>
                 </a:solidFill>
               </a:rPr>
-              <a:t>The quality gate warns above 0.15; deployment needs equity review.</a:t>
+              <a:t>gender: beyond chance overall, but explained by which modules the groups study</a:t>
             </a:r>
           </a:p>
           <a:p>
@@ -6572,12 +7783,87 @@
               </a:spcAft>
             </a:pPr>
             <a:r>
-              <a:rPr sz="1500" b="0">
+              <a:rPr sz="1300" b="0">
                 <a:solidFill>
                   <a:srgbClr val="1F2A44"/>
                 </a:solidFill>
               </a:rPr>
-              <a:t>One institution, 2013–14 data: revalidate before use elsewhere.</a:t>
+              <a:t>region: within chance</a:t>
+            </a:r>
+          </a:p>
+          <a:p>
+            <a:pPr>
+              <a:spcAft>
+                <a:spcPts val="800"/>
+              </a:spcAft>
+            </a:pPr>
+            <a:r>
+              <a:rPr sz="1300" b="0">
+                <a:solidFill>
+                  <a:srgbClr val="1F2A44"/>
+                </a:solidFill>
+              </a:rPr>
+              <a:t>highest_education: within chance</a:t>
+            </a:r>
+          </a:p>
+          <a:p>
+            <a:pPr>
+              <a:spcAft>
+                <a:spcPts val="800"/>
+              </a:spcAft>
+            </a:pPr>
+            <a:r>
+              <a:rPr sz="1300" b="0">
+                <a:solidFill>
+                  <a:srgbClr val="1F2A44"/>
+                </a:solidFill>
+              </a:rPr>
+              <a:t>imd_band: within chance</a:t>
+            </a:r>
+          </a:p>
+          <a:p>
+            <a:pPr>
+              <a:spcAft>
+                <a:spcPts val="800"/>
+              </a:spcAft>
+            </a:pPr>
+            <a:r>
+              <a:rPr sz="1300" b="0">
+                <a:solidFill>
+                  <a:srgbClr val="1F2A44"/>
+                </a:solidFill>
+              </a:rPr>
+              <a:t>age_band: within chance</a:t>
+            </a:r>
+          </a:p>
+          <a:p>
+            <a:pPr>
+              <a:spcAft>
+                <a:spcPts val="800"/>
+              </a:spcAft>
+            </a:pPr>
+            <a:r>
+              <a:rPr sz="1300" b="0">
+                <a:solidFill>
+                  <a:srgbClr val="1F2A44"/>
+                </a:solidFill>
+              </a:rPr>
+              <a:t>disability: beyond chance, also within modules</a:t>
+            </a:r>
+          </a:p>
+          <a:p>
+            <a:pPr>
+              <a:spcAft>
+                <a:spcPts val="800"/>
+              </a:spcAft>
+            </a:pPr>
+            <a:r>
+              <a:rPr sz="1300" b="0">
+                <a:solidFill>
+                  <a:srgbClr val="1F2A44"/>
+                </a:solidFill>
+              </a:rPr>
+              <a:t>Per-group cut-offs are shown for equity review, never applied.</a:t>
             </a:r>
           </a:p>
         </p:txBody>
@@ -6590,7 +7876,7 @@
 </p:sld>
 </file>
 
-<file path=ppt/slides/slide13.xml><?xml version="1.0" encoding="utf-8"?>
+<file path=ppt/slides/slide15.xml><?xml version="1.0" encoding="utf-8"?>
 <p:sld xmlns:a="http://schemas.openxmlformats.org/drawingml/2006/main" xmlns:p="http://schemas.openxmlformats.org/presentationml/2006/main" xmlns:r="http://schemas.openxmlformats.org/officeDocument/2006/relationships">
   <p:cSld>
     <p:bg>
@@ -7246,7 +8532,7 @@
         <p:spPr>
           <a:xfrm>
             <a:off x="365760" y="1143000"/>
-            <a:ext cx="7589520" cy="5275004"/>
+            <a:ext cx="7589520" cy="4816467"/>
           </a:xfrm>
           <a:prstGeom prst="rect">
             <a:avLst/>
@@ -7281,12 +8567,12 @@
               </a:spcAft>
             </a:pPr>
             <a:r>
-              <a:rPr sz="1600" b="0">
+              <a:rPr sz="1500" b="0">
                 <a:solidFill>
                   <a:srgbClr val="1F2A44"/>
                 </a:solidFill>
               </a:rPr>
-              <a:t>Offline build: features → calibrated models → prioritiser → historical-case index → evaluation and quality gate.</a:t>
+              <a:t>Offline build: features → calibrated models → prioritiser → case index in a LanceDB vector store → evaluation and gate.</a:t>
             </a:r>
           </a:p>
           <a:p>
@@ -7296,12 +8582,12 @@
               </a:spcAft>
             </a:pPr>
             <a:r>
-              <a:rPr sz="1600" b="0">
+              <a:rPr sz="1500" b="0">
                 <a:solidFill>
                   <a:srgbClr val="1F2A44"/>
                 </a:solidFill>
               </a:rPr>
-              <a:t>Online: API (auth, rate limit, strict validation) → service (real snapshots, what-if with imputation flags) → agent workflow.</a:t>
+              <a:t>Online: one FastAPI service (auth, rate limit, strict validation, streaming) → service layer → LangGraph agent workflow.</a:t>
             </a:r>
           </a:p>
           <a:p>
@@ -7311,12 +8597,12 @@
               </a:spcAft>
             </a:pPr>
             <a:r>
-              <a:rPr sz="1600" b="0">
+              <a:rPr sz="1500" b="0">
                 <a:solidFill>
                   <a:srgbClr val="1F2A44"/>
                 </a:solidFill>
               </a:rPr>
-              <a:t>LLM is optional and narrates only; facts, scores, priorities and eligible actions are computed in code.</a:t>
+              <a:t>Claude by task: Haiku parses, Sonnet writes, Opus judges. The LLM narrates only; facts, scores, priorities and eligible actions are computed in code, and everything works with the LLM off.</a:t>
             </a:r>
           </a:p>
           <a:p>
@@ -7326,7 +8612,7 @@
               </a:spcAft>
             </a:pPr>
             <a:r>
-              <a:rPr sz="1600" b="0">
+              <a:rPr sz="1500" b="0">
                 <a:solidFill>
                   <a:srgbClr val="1F2A44"/>
                 </a:solidFill>
@@ -8362,12 +9648,12 @@
               </a:spcAft>
             </a:pPr>
             <a:r>
-              <a:rPr sz="1500" b="0">
+              <a:rPr sz="1400" b="0">
                 <a:solidFill>
                   <a:srgbClr val="1F2A44"/>
                 </a:solidFill>
               </a:rPr>
-              <a:t>Metadata filters: module, presentation, region, education, age band, credits (range), previous attempts, outcome.</a:t>
+              <a:t>Vector database (LanceDB): filters on module, presentation, region, education, age band, credits (range), previous attempts and outcome run before an exact nearest-neighbour search.</a:t>
             </a:r>
           </a:p>
           <a:p>
@@ -8377,12 +9663,12 @@
               </a:spcAft>
             </a:pPr>
             <a:r>
-              <a:rPr sz="1500" b="0">
+              <a:rPr sz="1400" b="0">
                 <a:solidFill>
                   <a:srgbClr val="1F2A44"/>
                 </a:solidFill>
               </a:rPr>
-              <a:t>Each answer reports the outcome mix of the 50 nearest precedents with a 95% CI.</a:t>
+              <a:t>One document per enrolment; 6 precedent stories go to the agents, the outcome mix uses the 50 nearest with a 95% CI (top-K study in the model card).</a:t>
             </a:r>
           </a:p>
           <a:p>
@@ -8392,7 +9678,7 @@
               </a:spcAft>
             </a:pPr>
             <a:r>
-              <a:rPr sz="1500" b="0">
+              <a:rPr sz="1400" b="0">
                 <a:solidFill>
                   <a:srgbClr val="1F2A44"/>
                 </a:solidFill>

</xml_diff>

<commit_message>
Switch the dense channel to e5-small-v2
The embedding evaluation measured e5-small-v2 best; it is now the default with its
query/passage prefixes. The index manifest records the model and prefixes and queries
always use them. All indexes re-encoded and fusion weights re-tuned: rules-parser typed
search 0.622 -> 0.737 precision@10; week-15 profile retrieval unchanged. Docker bakes
e5; evaluate keeps the LLM-parser typed-search rows.

Co-Authored-By: Claude Opus 5.5 <noreply@anthropic.com>
</commit_message>
<xml_diff>
--- a/docs/Student_Success_Assistant_10min.pptx
+++ b/docs/Student_Success_Assistant_10min.pptx
@@ -1222,7 +1222,7 @@
                   <c:v>0.8364712918660288</c:v>
                 </c:pt>
                 <c:pt idx="3">
-                  <c:v>0.7747547846889953</c:v>
+                  <c:v>0.8304844497607655</c:v>
                 </c:pt>
                 <c:pt idx="4">
                   <c:v>0.5120334928229665</c:v>
@@ -1289,7 +1289,7 @@
                   <c:v>0.7541412072228056</c:v>
                 </c:pt>
                 <c:pt idx="3">
-                  <c:v>0.7235297564802611</c:v>
+                  <c:v>0.7320736152594541</c:v>
                 </c:pt>
                 <c:pt idx="4">
                   <c:v>0.5441068784899428</c:v>
@@ -7468,7 +7468,7 @@
                   <a:srgbClr val="1F2A44"/>
                 </a:solidFill>
               </a:rPr>
-              <a:t>In use: all-MiniLM-L6-v2 (full table in the model card).</a:t>
+              <a:t>In production: intfloat/e5-small-v2 (full table in the model card).</a:t>
             </a:r>
           </a:p>
         </p:txBody>

</xml_diff>

<commit_message>
Final console check: one week rule, honest as-of views, consistent labels
- One week rule everywhere (snapshot day // 7: weeks 5, 9, 15, 22); clock, pages, palette,
  landing, copilot tool, model card and deck agreed on different numbers before
- /api/config returns the temporal split; presentations are marked training, tuning or held out
- Case file: precedents use the plan's 6 cases; What-if shows withdrawal and fail-or-withdraw
- This week: no figures from after the selected week for upcoming assessments
- Copilot: ?q= asks once, retry no longer duplicates turns, rule answers labelled correctly
- Insights/Quality state their week; fairness follows the clock; feedback admin gating
- Docs: deduplicated a HANDOFF paragraph; week mentions and diagram updated

Co-Authored-By: Claude Opus 5.5 <noreply@anthropic.com>
</commit_message>
<xml_diff>
--- a/docs/Student_Success_Assistant_10min.pptx
+++ b/docs/Student_Success_Assistant_10min.pptx
@@ -694,7 +694,7 @@
               <c:strCache>
                 <c:ptCount val="4"/>
                 <c:pt idx="0">
-                  <c:v>week 6</c:v>
+                  <c:v>week 5</c:v>
                 </c:pt>
                 <c:pt idx="1">
                   <c:v>week 9</c:v>
@@ -755,7 +755,7 @@
               <c:strCache>
                 <c:ptCount val="4"/>
                 <c:pt idx="0">
-                  <c:v>week 6</c:v>
+                  <c:v>week 5</c:v>
                 </c:pt>
                 <c:pt idx="1">
                   <c:v>week 9</c:v>
@@ -816,7 +816,7 @@
               <c:strCache>
                 <c:ptCount val="4"/>
                 <c:pt idx="0">
-                  <c:v>week 6</c:v>
+                  <c:v>week 5</c:v>
                 </c:pt>
                 <c:pt idx="1">
                   <c:v>week 9</c:v>
@@ -9288,7 +9288,7 @@
                   <a:srgbClr val="1F2A44"/>
                 </a:solidFill>
               </a:rPr>
-              <a:t>Week 6: 27,157 still enrolled; week 22: 23,926.</a:t>
+              <a:t>Week 5: 27,157 still enrolled; week 22: 23,926.</a:t>
             </a:r>
           </a:p>
           <a:p>

</xml_diff>